<commit_message>
Add file_size column to CSV; seed cross-publication duplicate grams
Surfaces duplicate assets across publications during human CSV review:
file_size captures the on-disk byte count for each row's png_path
(Path.stat().st_size on the resolved file). Two rows pointing at
byte-identical assets share a file_size even when gram_id / vessel_name
have drifted, which is the dedup workflow the author wanted — sort by
file_size to spot duplicates, then either delete the duplicate rows or
clear topic_filename to mark "do not process".

Seeded three deliberate Week 1 / Progress Test 1 duplicates in the mock
corpus so the workflow has something to find: Gram 3 (two PNG lofars)
and Gram 7 (one WAV lofar) appear identically in both publications;
Gram 11 (three PNG lofars) shares byte-identical assets but its
vessel_name drifts in Test 1 ("...Risa" vs "...Risa (mark II)") to
exercise the name-drift case the column was added for.
</commit_message>
<xml_diff>
--- a/source/Instructor Progress Test 1 Grams/Instructor Progress Test 1 Grams.pptx
+++ b/source/Instructor Progress Test 1 Grams/Instructor Progress Test 1 Grams.pptx
@@ -3278,7 +3278,7 @@
                   <a:srgbClr val="1F3A5F"/>
                 </a:solidFill>
               </a:rPr>
-              <a:t>Gram 1: FR Prometheus, Category 1, Bespin</a:t>
+              <a:t>Gram 3: FR Constitution-class, Category 2, Endor</a:t>
             </a:r>
           </a:p>
         </p:txBody>
@@ -3372,7 +3372,7 @@
                   <a:srgbClr val="1F3A5F"/>
                 </a:solidFill>
               </a:rPr>
-              <a:t>Gram 3: FR Ghost, Category 1, Tantive</a:t>
+              <a:t>Gram 7: FR Defiant, Category 1, Vulcan</a:t>
             </a:r>
           </a:p>
         </p:txBody>
@@ -3458,7 +3458,7 @@
                   <a:srgbClr val="1F3A5F"/>
                 </a:solidFill>
               </a:rPr>
-              <a:t>Gram 4: Enterprise contact bearing 291, codename Hoth</a:t>
+              <a:t>Gram 11: FR Voyager, Category 3, Risa (mark II)</a:t>
             </a:r>
           </a:p>
         </p:txBody>
@@ -3492,12 +3492,28 @@
               <a:t>Lofar 1</a:t>
             </a:r>
           </a:p>
+          <a:p>
+            <a:r>
+              <a:rPr sz="800">
+                <a:hlinkClick r:id="rId9"/>
+              </a:rPr>
+              <a:t>Lofar 2</a:t>
+            </a:r>
+          </a:p>
+          <a:p>
+            <a:r>
+              <a:rPr sz="800">
+                <a:hlinkClick r:id="rId10"/>
+              </a:rPr>
+              <a:t>Lofar 3</a:t>
+            </a:r>
+          </a:p>
         </p:txBody>
       </p:sp>
       <p:sp>
         <p:nvSpPr>
           <p:cNvPr id="9" name="Rounded Rectangle 8">
-            <a:hlinkClick r:id="rId9"/>
+            <a:hlinkClick r:id="rId11"/>
           </p:cNvPr>
           <p:cNvSpPr/>
           <p:nvPr/>
@@ -3544,7 +3560,7 @@
                   <a:srgbClr val="1F3A5F"/>
                 </a:solidFill>
               </a:rPr>
-              <a:t>Gram 5: FR Enterprise, Category 4, Bespin</a:t>
+              <a:t>Gram 1: FR Prometheus, Category 1, Bespin</a:t>
             </a:r>
           </a:p>
         </p:txBody>
@@ -3573,17 +3589,25 @@
           <a:p>
             <a:r>
               <a:rPr sz="800">
-                <a:hlinkClick r:id="rId10"/>
+                <a:hlinkClick r:id="rId12"/>
               </a:rPr>
               <a:t>Lofar 1</a:t>
             </a:r>
           </a:p>
+          <a:p>
+            <a:r>
+              <a:rPr sz="800">
+                <a:hlinkClick r:id="rId13"/>
+              </a:rPr>
+              <a:t>Lofar 2</a:t>
+            </a:r>
+          </a:p>
         </p:txBody>
       </p:sp>
       <p:sp>
         <p:nvSpPr>
           <p:cNvPr id="11" name="Rounded Rectangle 10">
-            <a:hlinkClick r:id="rId11"/>
+            <a:hlinkClick r:id="rId14"/>
           </p:cNvPr>
           <p:cNvSpPr/>
           <p:nvPr/>
@@ -3630,7 +3654,7 @@
                   <a:srgbClr val="1F3A5F"/>
                 </a:solidFill>
               </a:rPr>
-              <a:t>Gram 6: FR Akira-class, Category 4, Hoth</a:t>
+              <a:t>Gram 4: Enterprise contact bearing 291, codename Hoth</a:t>
             </a:r>
           </a:p>
         </p:txBody>
@@ -3659,7 +3683,7 @@
           <a:p>
             <a:r>
               <a:rPr sz="800">
-                <a:hlinkClick r:id="rId12"/>
+                <a:hlinkClick r:id="rId15"/>
               </a:rPr>
               <a:t>Lofar 1</a:t>
             </a:r>
@@ -3669,7 +3693,7 @@
       <p:sp>
         <p:nvSpPr>
           <p:cNvPr id="13" name="Rounded Rectangle 12">
-            <a:hlinkClick r:id="rId13"/>
+            <a:hlinkClick r:id="rId16"/>
           </p:cNvPr>
           <p:cNvSpPr/>
           <p:nvPr/>
@@ -3716,7 +3740,7 @@
                   <a:srgbClr val="1F3A5F"/>
                 </a:solidFill>
               </a:rPr>
-              <a:t>Gram 7: FR Rebel One, Category 1, Naboo</a:t>
+              <a:t>Gram 5: FR Enterprise, Category 4, Bespin</a:t>
             </a:r>
           </a:p>
         </p:txBody>
@@ -3745,25 +3769,17 @@
           <a:p>
             <a:r>
               <a:rPr sz="800">
-                <a:hlinkClick r:id="rId14"/>
+                <a:hlinkClick r:id="rId17"/>
               </a:rPr>
               <a:t>Lofar 1</a:t>
             </a:r>
           </a:p>
-          <a:p>
-            <a:r>
-              <a:rPr sz="800">
-                <a:hlinkClick r:id="rId15"/>
-              </a:rPr>
-              <a:t>Lofar 2</a:t>
-            </a:r>
-          </a:p>
         </p:txBody>
       </p:sp>
       <p:sp>
         <p:nvSpPr>
           <p:cNvPr id="15" name="Rounded Rectangle 14">
-            <a:hlinkClick r:id="rId16"/>
+            <a:hlinkClick r:id="rId18"/>
           </p:cNvPr>
           <p:cNvSpPr/>
           <p:nvPr/>
@@ -3810,7 +3826,7 @@
                   <a:srgbClr val="1F3A5F"/>
                 </a:solidFill>
               </a:rPr>
-              <a:t>Gram 8: FR TIE Bomber, Category 4, Kronos</a:t>
+              <a:t>Gram 6: FR Akira-class, Category 4, Hoth</a:t>
             </a:r>
           </a:p>
         </p:txBody>
@@ -3839,7 +3855,7 @@
           <a:p>
             <a:r>
               <a:rPr sz="800">
-                <a:hlinkClick r:id="rId17"/>
+                <a:hlinkClick r:id="rId19"/>
               </a:rPr>
               <a:t>Lofar 1</a:t>
             </a:r>
@@ -3849,7 +3865,7 @@
       <p:sp>
         <p:nvSpPr>
           <p:cNvPr id="17" name="Rounded Rectangle 16">
-            <a:hlinkClick r:id="rId18"/>
+            <a:hlinkClick r:id="rId20"/>
           </p:cNvPr>
           <p:cNvSpPr/>
           <p:nvPr/>
@@ -3896,7 +3912,7 @@
                   <a:srgbClr val="1F3A5F"/>
                 </a:solidFill>
               </a:rPr>
-              <a:t>Gram 9: FR Star Destroyer, Category 1, Tatooine</a:t>
+              <a:t>Gram 8: FR TIE Bomber, Category 4, Kronos</a:t>
             </a:r>
           </a:p>
         </p:txBody>
@@ -3925,7 +3941,7 @@
           <a:p>
             <a:r>
               <a:rPr sz="800">
-                <a:hlinkClick r:id="rId19"/>
+                <a:hlinkClick r:id="rId21"/>
               </a:rPr>
               <a:t>Lofar 1</a:t>
             </a:r>
@@ -3935,7 +3951,7 @@
       <p:sp>
         <p:nvSpPr>
           <p:cNvPr id="19" name="Rounded Rectangle 18">
-            <a:hlinkClick r:id="rId20"/>
+            <a:hlinkClick r:id="rId22"/>
           </p:cNvPr>
           <p:cNvSpPr/>
           <p:nvPr/>
@@ -3982,7 +3998,7 @@
                   <a:srgbClr val="1F3A5F"/>
                 </a:solidFill>
               </a:rPr>
-              <a:t>Gram 10: FR Stargazer, Category 3, Risa</a:t>
+              <a:t>Gram 9: FR Star Destroyer, Category 1, Tatooine</a:t>
             </a:r>
           </a:p>
         </p:txBody>
@@ -4011,41 +4027,17 @@
           <a:p>
             <a:r>
               <a:rPr sz="800">
-                <a:hlinkClick r:id="rId21"/>
+                <a:hlinkClick r:id="rId23"/>
               </a:rPr>
               <a:t>Lofar 1</a:t>
             </a:r>
           </a:p>
-          <a:p>
-            <a:r>
-              <a:rPr sz="800">
-                <a:hlinkClick r:id="rId22"/>
-              </a:rPr>
-              <a:t>Lofar 2</a:t>
-            </a:r>
-          </a:p>
-          <a:p>
-            <a:r>
-              <a:rPr sz="800">
-                <a:hlinkClick r:id="rId23"/>
-              </a:rPr>
-              <a:t>Lofar 3</a:t>
-            </a:r>
-          </a:p>
-          <a:p>
-            <a:r>
-              <a:rPr sz="800">
-                <a:hlinkClick r:id="rId24"/>
-              </a:rPr>
-              <a:t>Lofar 4</a:t>
-            </a:r>
-          </a:p>
         </p:txBody>
       </p:sp>
       <p:sp>
         <p:nvSpPr>
           <p:cNvPr id="21" name="Rounded Rectangle 20">
-            <a:hlinkClick r:id="rId25"/>
+            <a:hlinkClick r:id="rId24"/>
           </p:cNvPr>
           <p:cNvSpPr/>
           <p:nvPr/>
@@ -4092,7 +4084,7 @@
                   <a:srgbClr val="1F3A5F"/>
                 </a:solidFill>
               </a:rPr>
-              <a:t>Gram 11: FR Imperial-class, Category 2, Caprica</a:t>
+              <a:t>Gram 10: FR Stargazer, Category 3, Risa</a:t>
             </a:r>
           </a:p>
         </p:txBody>
@@ -4121,9 +4113,17 @@
           <a:p>
             <a:r>
               <a:rPr sz="800">
+                <a:hlinkClick r:id="rId25"/>
+              </a:rPr>
+              <a:t>Lofar 1</a:t>
+            </a:r>
+          </a:p>
+          <a:p>
+            <a:r>
+              <a:rPr sz="800">
                 <a:hlinkClick r:id="rId26"/>
               </a:rPr>
-              <a:t>Lofar 1</a:t>
+              <a:t>Lofar 2</a:t>
             </a:r>
           </a:p>
           <a:p>
@@ -4131,7 +4131,15 @@
               <a:rPr sz="800">
                 <a:hlinkClick r:id="rId27"/>
               </a:rPr>
-              <a:t>Lofar 2</a:t>
+              <a:t>Lofar 3</a:t>
+            </a:r>
+          </a:p>
+          <a:p>
+            <a:r>
+              <a:rPr sz="800">
+                <a:hlinkClick r:id="rId28"/>
+              </a:rPr>
+              <a:t>Lofar 4</a:t>
             </a:r>
           </a:p>
         </p:txBody>
@@ -4139,7 +4147,7 @@
       <p:sp>
         <p:nvSpPr>
           <p:cNvPr id="23" name="Rounded Rectangle 22">
-            <a:hlinkClick r:id="rId28"/>
+            <a:hlinkClick r:id="rId29"/>
           </p:cNvPr>
           <p:cNvSpPr/>
           <p:nvPr/>
@@ -4215,7 +4223,7 @@
           <a:p>
             <a:r>
               <a:rPr sz="800">
-                <a:hlinkClick r:id="rId29"/>
+                <a:hlinkClick r:id="rId30"/>
               </a:rPr>
               <a:t>Lofar 1</a:t>
             </a:r>
@@ -4225,7 +4233,7 @@
       <p:sp>
         <p:nvSpPr>
           <p:cNvPr id="25" name="Rounded Rectangle 24">
-            <a:hlinkClick r:id="rId30"/>
+            <a:hlinkClick r:id="rId31"/>
           </p:cNvPr>
           <p:cNvSpPr/>
           <p:nvPr/>
@@ -4301,17 +4309,9 @@
           <a:p>
             <a:r>
               <a:rPr sz="800">
-                <a:hlinkClick r:id="rId31"/>
+                <a:hlinkClick r:id="rId32"/>
               </a:rPr>
               <a:t>Lofar 1</a:t>
-            </a:r>
-          </a:p>
-          <a:p>
-            <a:r>
-              <a:rPr sz="800">
-                <a:hlinkClick r:id="rId32"/>
-              </a:rPr>
-              <a:t>Lofar 2</a:t>
             </a:r>
           </a:p>
           <a:p>
@@ -4319,7 +4319,7 @@
               <a:rPr sz="800">
                 <a:hlinkClick r:id="rId33"/>
               </a:rPr>
-              <a:t>Lofar 3</a:t>
+              <a:t>Lofar 2</a:t>
             </a:r>
           </a:p>
           <a:p>
@@ -4327,6 +4327,14 @@
               <a:rPr sz="800">
                 <a:hlinkClick r:id="rId34"/>
               </a:rPr>
+              <a:t>Lofar 3</a:t>
+            </a:r>
+          </a:p>
+          <a:p>
+            <a:r>
+              <a:rPr sz="800">
+                <a:hlinkClick r:id="rId35"/>
+              </a:rPr>
               <a:t>Lofar 4</a:t>
             </a:r>
           </a:p>
@@ -4335,7 +4343,7 @@
       <p:sp>
         <p:nvSpPr>
           <p:cNvPr id="27" name="Rounded Rectangle 26">
-            <a:hlinkClick r:id="rId35"/>
+            <a:hlinkClick r:id="rId36"/>
           </p:cNvPr>
           <p:cNvSpPr/>
           <p:nvPr/>
@@ -4411,7 +4419,7 @@
           <a:p>
             <a:r>
               <a:rPr sz="800">
-                <a:hlinkClick r:id="rId36"/>
+                <a:hlinkClick r:id="rId37"/>
               </a:rPr>
               <a:t>Lofar 1</a:t>
             </a:r>
@@ -4419,7 +4427,7 @@
           <a:p>
             <a:r>
               <a:rPr sz="800">
-                <a:hlinkClick r:id="rId37"/>
+                <a:hlinkClick r:id="rId38"/>
               </a:rPr>
               <a:t>Lofar 2</a:t>
             </a:r>
@@ -4429,7 +4437,7 @@
       <p:sp>
         <p:nvSpPr>
           <p:cNvPr id="29" name="Rounded Rectangle 28">
-            <a:hlinkClick r:id="rId38"/>
+            <a:hlinkClick r:id="rId39"/>
           </p:cNvPr>
           <p:cNvSpPr/>
           <p:nvPr/>
@@ -4505,17 +4513,9 @@
           <a:p>
             <a:r>
               <a:rPr sz="800">
-                <a:hlinkClick r:id="rId39"/>
+                <a:hlinkClick r:id="rId40"/>
               </a:rPr>
               <a:t>Lofar 1</a:t>
-            </a:r>
-          </a:p>
-          <a:p>
-            <a:r>
-              <a:rPr sz="800">
-                <a:hlinkClick r:id="rId40"/>
-              </a:rPr>
-              <a:t>Lofar 2</a:t>
             </a:r>
           </a:p>
           <a:p>
@@ -4523,7 +4523,7 @@
               <a:rPr sz="800">
                 <a:hlinkClick r:id="rId41"/>
               </a:rPr>
-              <a:t>Lofar 3</a:t>
+              <a:t>Lofar 2</a:t>
             </a:r>
           </a:p>
           <a:p>
@@ -4531,6 +4531,14 @@
               <a:rPr sz="800">
                 <a:hlinkClick r:id="rId42"/>
               </a:rPr>
+              <a:t>Lofar 3</a:t>
+            </a:r>
+          </a:p>
+          <a:p>
+            <a:r>
+              <a:rPr sz="800">
+                <a:hlinkClick r:id="rId43"/>
+              </a:rPr>
               <a:t>Lofar 4</a:t>
             </a:r>
           </a:p>
@@ -4539,7 +4547,7 @@
       <p:sp>
         <p:nvSpPr>
           <p:cNvPr id="31" name="Rounded Rectangle 30">
-            <a:hlinkClick r:id="rId43"/>
+            <a:hlinkClick r:id="rId44"/>
           </p:cNvPr>
           <p:cNvSpPr/>
           <p:nvPr/>
@@ -4615,7 +4623,7 @@
           <a:p>
             <a:r>
               <a:rPr sz="800">
-                <a:hlinkClick r:id="rId44"/>
+                <a:hlinkClick r:id="rId45"/>
               </a:rPr>
               <a:t>Lofar 1</a:t>
             </a:r>

</xml_diff>